<commit_message>
Match próstata: clips anotados (cuadro rotulado + barrido) en cada lámina de caso
Co-Authored-By: Claude Fable 5.1 <noreply@anthropic.com>
Claude-Session: https://claude.ai/code/session_01ULRY7Vd3j1Y2aQaqmzKdgd
</commit_message>
<xml_diff>
--- a/resumen-videos/resultados/Match_prostata/Match CBCT-TAC prostata (INC) - sin videos.pptx
+++ b/resumen-videos/resultados/Match_prostata/Match CBCT-TAC prostata (INC) - sin videos.pptx
@@ -2416,7 +2416,7 @@
                 <a:ea typeface="Calibri" pitchFamily="34" charset="-122"/>
                 <a:cs typeface="Calibri" pitchFamily="34" charset="-120"/>
               </a:rPr>
-              <a:t>Casos reales de la sala de tratamiento · 5 pacientes · 8 clips</a:t>
+              <a:t>Casos reales de la sala de tratamiento · 5 pacientes · las imágenes de los casos son clips: clic para reproducir</a:t>
             </a:r>
             <a:endParaRPr lang="en-US" sz="1400" dirty="0"/>
           </a:p>
@@ -10269,7 +10269,7 @@
       </p:graphicFrame>
       <p:pic>
         <p:nvPicPr>
-          <p:cNvPr id="5" name="Image 0" descr="/tmp/claude-0/-home-user-telon/44f4c94a-cd0b-5d39-be5e-ac4d3f8deac5/scratchpad/match/material/IMG_5043/02_recorte.jpg">    </p:cNvPr>
+          <p:cNvPr id="5" name="Image 0" descr="/tmp/claude-0/-home-user-telon/44f4c94a-cd0b-5d39-be5e-ac4d3f8deac5/scratchpad/match/material/IMG_5043/02_rotulado.jpg">    </p:cNvPr>
           <p:cNvPicPr>
             <a:picLocks noChangeAspect="1"/>
           </p:cNvPicPr>
@@ -10283,8 +10283,8 @@
         </p:blipFill>
         <p:spPr>
           <a:xfrm>
-            <a:off x="8242935" y="1645920"/>
-            <a:ext cx="3265170" cy="2743200"/>
+            <a:off x="8395090" y="1645920"/>
+            <a:ext cx="2960859" cy="2743200"/>
           </a:xfrm>
           <a:prstGeom prst="rect">
             <a:avLst/>

</xml_diff>